<commit_message>
Figma plugin: add the technician's finished-jobs tab and completed job screen
The technician flow ended at the completion sheet with nowhere to land.
Adds T01f (งานของฉัน · เสร็จแล้ว) and T02f (รายละเอียดงาน ซ่อมเสร็จ), links the
เสร็จแล้ว tab, and sends ยืนยันซ่อมเสร็จ to the finished job. Each set now has
76 screens and 401 interactions; report and slides updated to match.

Co-Authored-By: Claude Opus 5 <noreply@anthropic.com>
</commit_message>
<xml_diff>
--- a/report/out/สไลด์-ระบบแจ้งซ่อม-มช.pptx
+++ b/report/out/สไลด์-ระบบแจ้งซ่อม-มช.pptx
@@ -4173,7 +4173,7 @@
                 <a:ea typeface="Leelawadee UI" pitchFamily="34" charset="-122"/>
                 <a:cs typeface="Leelawadee UI" pitchFamily="34" charset="-120"/>
               </a:rPr>
-              <a:t>72</a:t>
+              <a:t>76</a:t>
             </a:r>
             <a:endParaRPr lang="en-US" sz="4000" dirty="0"/>
           </a:p>
@@ -4383,7 +4383,7 @@
                 <a:ea typeface="Leelawadee UI" pitchFamily="34" charset="-122"/>
                 <a:cs typeface="Leelawadee UI" pitchFamily="34" charset="-120"/>
               </a:rPr>
-              <a:t>367</a:t>
+              <a:t>401</a:t>
             </a:r>
             <a:endParaRPr lang="en-US" sz="4000" dirty="0"/>
           </a:p>

</xml_diff>

<commit_message>
Report: activity diagram for the dashboard, main activities per sprint, 5-member cover
Matches the course brief: activity diagrams for the three core functions and the
additional function, and the main activities and outputs of each iteration.

Co-Authored-By: Claude Opus 5 <noreply@anthropic.com>
</commit_message>
<xml_diff>
--- a/report/out/สไลด์-ระบบแจ้งซ่อม-มช.pptx
+++ b/report/out/สไลด์-ระบบแจ้งซ่อม-มช.pptx
@@ -2621,7 +2621,7 @@
                 <a:ea typeface="Leelawadee UI" pitchFamily="34" charset="-122"/>
                 <a:cs typeface="Leelawadee UI" pitchFamily="34" charset="-120"/>
               </a:rPr>
-              <a:t>แจ้งซ่อม และ งานซ่อมของช่าง</a:t>
+              <a:t>ฟังก์ชันหลักที่ 1 แจ้งซ่อม · ฟังก์ชันหลักที่ 3 งานของช่าง</a:t>
             </a:r>
             <a:endParaRPr lang="en-US" sz="2800" dirty="0"/>
           </a:p>
@@ -2945,7 +2945,7 @@
                 <a:ea typeface="Leelawadee UI" pitchFamily="34" charset="-122"/>
                 <a:cs typeface="Leelawadee UI" pitchFamily="34" charset="-120"/>
               </a:rPr>
-              <a:t>คัดกรอง → มอบหมาย → ยืนยันผล</a:t>
+              <a:t>ติดตามสถานะ · แดชบอร์ด · วงจรคำร้อง</a:t>
             </a:r>
             <a:endParaRPr lang="en-US" sz="2800" dirty="0"/>
           </a:p>
@@ -2992,7 +2992,7 @@
       </p:sp>
       <p:pic>
         <p:nvPicPr>
-          <p:cNvPr id="5" name="Image 0" descr="C:\Users\namai\OneDrive\เอกสาร\Maintenance System\report\out\diagrams\activity-admin.png">    </p:cNvPr>
+          <p:cNvPr id="5" name="Image 0" descr="C:\Users\namai\OneDrive\เอกสาร\Maintenance System\report\out\diagrams\activity-confirm.png">    </p:cNvPr>
           <p:cNvPicPr>
             <a:picLocks noChangeAspect="1"/>
           </p:cNvPicPr>
@@ -3006,8 +3006,8 @@
         </p:blipFill>
         <p:spPr>
           <a:xfrm>
-            <a:off x="549573" y="1371600"/>
-            <a:ext cx="2741334" cy="5349240"/>
+            <a:off x="393844" y="1371600"/>
+            <a:ext cx="4881592" cy="2834640"/>
           </a:xfrm>
           <a:prstGeom prst="rect">
             <a:avLst/>
@@ -3016,7 +3016,7 @@
       </p:pic>
       <p:pic>
         <p:nvPicPr>
-          <p:cNvPr id="6" name="Image 1" descr="C:\Users\namai\OneDrive\เอกสาร\Maintenance System\report\out\diagrams\activity-confirm.png">    </p:cNvPr>
+          <p:cNvPr id="6" name="Image 1" descr="C:\Users\namai\OneDrive\เอกสาร\Maintenance System\report\out\diagrams\activity-dashboard.png">    </p:cNvPr>
           <p:cNvPicPr>
             <a:picLocks noChangeAspect="1"/>
           </p:cNvPicPr>
@@ -3030,8 +3030,8 @@
         </p:blipFill>
         <p:spPr>
           <a:xfrm>
-            <a:off x="3568835" y="1463040"/>
-            <a:ext cx="4566651" cy="2651760"/>
+            <a:off x="5767643" y="1371600"/>
+            <a:ext cx="2089274" cy="5349240"/>
           </a:xfrm>
           <a:prstGeom prst="rect">
             <a:avLst/>
@@ -3054,7 +3054,7 @@
         </p:blipFill>
         <p:spPr>
           <a:xfrm>
-            <a:off x="8711444" y="1371600"/>
+            <a:off x="8802884" y="1371600"/>
             <a:ext cx="2693912" cy="5349240"/>
           </a:xfrm>
           <a:prstGeom prst="rect">
@@ -3070,8 +3070,8 @@
         </p:nvSpPr>
         <p:spPr>
           <a:xfrm>
-            <a:off x="3566160" y="4389120"/>
-            <a:ext cx="4572000" cy="1645920"/>
+            <a:off x="365760" y="4480560"/>
+            <a:ext cx="4937760" cy="2011680"/>
           </a:xfrm>
           <a:prstGeom prst="rect">
             <a:avLst/>
@@ -3083,11 +3083,15 @@
           <a:bodyPr wrap="square" rtlCol="0" anchor="t"/>
           <a:lstStyle/>
           <a:p>
-            <a:pPr indent="0" marL="0">
-              <a:buNone/>
-            </a:pPr>
-            <a:r>
-              <a:rPr lang="en-US" sz="1500" dirty="0">
+            <a:pPr marL="228600" indent="-228600">
+              <a:spcAft>
+                <a:spcPts val="800"/>
+              </a:spcAft>
+              <a:buSzPct val="100000"/>
+              <a:buChar char="•"/>
+            </a:pPr>
+            <a:r>
+              <a:rPr lang="en-US" sz="1400" dirty="0">
                 <a:solidFill>
                   <a:srgbClr val="111111"/>
                 </a:solidFill>
@@ -3095,43 +3099,51 @@
                 <a:ea typeface="Leelawadee UI" pitchFamily="34" charset="-122"/>
                 <a:cs typeface="Leelawadee UI" pitchFamily="34" charset="-120"/>
               </a:rPr>
+              <a:t>ฟังก์ชันหลักที่ 2: ยืนยัน + ให้ดาว หรือ "ยังไม่หาย" ครบ 3 วันปิดอัตโนมัติ</a:t>
+            </a:r>
+            <a:endParaRPr lang="en-US" sz="1400" dirty="0"/>
+          </a:p>
+          <a:p>
+            <a:pPr marL="228600" indent="-228600">
+              <a:spcAft>
+                <a:spcPts val="800"/>
+              </a:spcAft>
+              <a:buSzPct val="100000"/>
+              <a:buChar char="•"/>
+            </a:pPr>
+            <a:r>
+              <a:rPr lang="en-US" sz="1400" dirty="0">
+                <a:solidFill>
+                  <a:srgbClr val="111111"/>
+                </a:solidFill>
+                <a:latin typeface="Leelawadee UI" pitchFamily="34" charset="0"/>
+                <a:ea typeface="Leelawadee UI" pitchFamily="34" charset="-122"/>
+                <a:cs typeface="Leelawadee UI" pitchFamily="34" charset="-120"/>
+              </a:rPr>
+              <a:t>ฟังก์ชันเพิ่มเติม: เลือกช่วงเวลา → KPI/แผนภูมิ → ส่งออก Excel/PDF</a:t>
+            </a:r>
+            <a:endParaRPr lang="en-US" sz="1400" dirty="0"/>
+          </a:p>
+          <a:p>
+            <a:pPr marL="228600" indent="-228600">
+              <a:spcAft>
+                <a:spcPts val="800"/>
+              </a:spcAft>
+              <a:buSzPct val="100000"/>
+              <a:buChar char="•"/>
+            </a:pPr>
+            <a:r>
+              <a:rPr lang="en-US" sz="1400" dirty="0">
+                <a:solidFill>
+                  <a:srgbClr val="111111"/>
+                </a:solidFill>
+                <a:latin typeface="Leelawadee UI" pitchFamily="34" charset="0"/>
+                <a:ea typeface="Leelawadee UI" pitchFamily="34" charset="-122"/>
+                <a:cs typeface="Leelawadee UI" pitchFamily="34" charset="-120"/>
+              </a:rPr>
               <a:t>10 สถานะ ควบคุมที่ฟังก์ชันเดียวฝั่งเซิร์ฟเวอร์</a:t>
             </a:r>
-            <a:endParaRPr lang="en-US" sz="1500" dirty="0"/>
-          </a:p>
-          <a:p>
-            <a:pPr indent="0" marL="0">
-              <a:buNone/>
-            </a:pPr>
-            <a:r>
-              <a:rPr lang="en-US" sz="1500" dirty="0">
-                <a:solidFill>
-                  <a:srgbClr val="111111"/>
-                </a:solidFill>
-                <a:latin typeface="Leelawadee UI" pitchFamily="34" charset="0"/>
-                <a:ea typeface="Leelawadee UI" pitchFamily="34" charset="-122"/>
-                <a:cs typeface="Leelawadee UI" pitchFamily="34" charset="-120"/>
-              </a:rPr>
-              <a:t>ยืนยัน / ครบ 3 วัน → ปิดงาน</a:t>
-            </a:r>
-            <a:endParaRPr lang="en-US" sz="1500" dirty="0"/>
-          </a:p>
-          <a:p>
-            <a:pPr indent="0" marL="0">
-              <a:buNone/>
-            </a:pPr>
-            <a:r>
-              <a:rPr lang="en-US" sz="1500" dirty="0">
-                <a:solidFill>
-                  <a:srgbClr val="111111"/>
-                </a:solidFill>
-                <a:latin typeface="Leelawadee UI" pitchFamily="34" charset="0"/>
-                <a:ea typeface="Leelawadee UI" pitchFamily="34" charset="-122"/>
-                <a:cs typeface="Leelawadee UI" pitchFamily="34" charset="-120"/>
-              </a:rPr>
-              <a:t>ยังไม่หาย → กลับไปรับเรื่องแล้ว</a:t>
-            </a:r>
-            <a:endParaRPr lang="en-US" sz="1500" dirty="0"/>
+            <a:endParaRPr lang="en-US" sz="1400" dirty="0"/>
           </a:p>
         </p:txBody>
       </p:sp>
@@ -9734,7 +9746,7 @@
                 <a:ea typeface="Leelawadee UI" pitchFamily="34" charset="-122"/>
                 <a:cs typeface="Leelawadee UI" pitchFamily="34" charset="-120"/>
               </a:rPr>
-              <a:t>bcrypt + HTTPS</a:t>
+              <a:t>bcrypt + HTTPS + จำกัดรหัสผิด 5 ครั้ง</a:t>
             </a:r>
             <a:endParaRPr lang="en-US" sz="1400" dirty="0"/>
           </a:p>

</xml_diff>

<commit_message>
Figma and report: match the mobile admin menu and this round's fixes
- Plugin: admin top bar on phones uses three icon-over-label buttons with
  short labels, like the web app
- Report and slides: building search in FR-04, security and UI review rows in
  the feedback tables; screenshots re-rendered

Co-Authored-By: Claude Opus 5 <noreply@anthropic.com>
</commit_message>
<xml_diff>
--- a/report/out/สไลด์-ระบบแจ้งซ่อม-มช.pptx
+++ b/report/out/สไลด์-ระบบแจ้งซ่อม-มช.pptx
@@ -12234,7 +12234,7 @@
                 <a:gridCol w="4754880"/>
                 <a:gridCol w="6309360"/>
               </a:tblGrid>
-              <a:tr h="566928">
+              <a:tr h="512064">
                 <a:tc>
                   <a:txBody>
                     <a:bodyPr/>
@@ -12244,7 +12244,7 @@
                         <a:buNone/>
                       </a:pPr>
                       <a:r>
-                        <a:rPr lang="en-US" sz="1500" b="1" dirty="0">
+                        <a:rPr lang="en-US" sz="1400" b="1" dirty="0">
                           <a:solidFill>
                             <a:srgbClr val="FFFFFF"/>
                           </a:solidFill>
@@ -12254,7 +12254,7 @@
                         </a:rPr>
                         <a:t>ข้อเสนอแนะ / ปัญหาที่พบ</a:t>
                       </a:r>
-                      <a:endParaRPr lang="en-US" sz="1500" dirty="0">
+                      <a:endParaRPr lang="en-US" sz="1400" dirty="0">
                         <a:latin typeface="Leelawadee UI" charset="0"/>
                         <a:ea typeface="Leelawadee UI" charset="0"/>
                         <a:cs typeface="Leelawadee UI" charset="0"/>
@@ -12312,7 +12312,7 @@
                         <a:buNone/>
                       </a:pPr>
                       <a:r>
-                        <a:rPr lang="en-US" sz="1500" b="1" dirty="0">
+                        <a:rPr lang="en-US" sz="1400" b="1" dirty="0">
                           <a:solidFill>
                             <a:srgbClr val="FFFFFF"/>
                           </a:solidFill>
@@ -12322,7 +12322,7 @@
                         </a:rPr>
                         <a:t>สิ่งที่ปรับปรุง</a:t>
                       </a:r>
-                      <a:endParaRPr lang="en-US" sz="1500" dirty="0">
+                      <a:endParaRPr lang="en-US" sz="1400" dirty="0">
                         <a:latin typeface="Leelawadee UI" charset="0"/>
                         <a:ea typeface="Leelawadee UI" charset="0"/>
                         <a:cs typeface="Leelawadee UI" charset="0"/>
@@ -12372,7 +12372,7 @@
                   </a:tcPr>
                 </a:tc>
               </a:tr>
-              <a:tr h="566928">
+              <a:tr h="512064">
                 <a:tc>
                   <a:txBody>
                     <a:bodyPr/>
@@ -12382,7 +12382,7 @@
                         <a:buNone/>
                       </a:pPr>
                       <a:r>
-                        <a:rPr lang="en-US" sz="1500" dirty="0">
+                        <a:rPr lang="en-US" sz="1400" dirty="0">
                           <a:solidFill>
                             <a:srgbClr val="111111"/>
                           </a:solidFill>
@@ -12392,7 +12392,7 @@
                         </a:rPr>
                         <a:t>หน้าคอมพิวเตอร์ยังเป็นแบบมือถือ</a:t>
                       </a:r>
-                      <a:endParaRPr lang="en-US" sz="1500" dirty="0">
+                      <a:endParaRPr lang="en-US" sz="1400" dirty="0">
                         <a:latin typeface="Leelawadee UI" charset="0"/>
                         <a:ea typeface="Leelawadee UI" charset="0"/>
                         <a:cs typeface="Leelawadee UI" charset="0"/>
@@ -12450,7 +12450,7 @@
                         <a:buNone/>
                       </a:pPr>
                       <a:r>
-                        <a:rPr lang="en-US" sz="1500" dirty="0">
+                        <a:rPr lang="en-US" sz="1400" dirty="0">
                           <a:solidFill>
                             <a:srgbClr val="111111"/>
                           </a:solidFill>
@@ -12460,7 +12460,7 @@
                         </a:rPr>
                         <a:t>แยกเลย์เอาต์เดสก์ท็อป เมนูซ้าย 2 คอลัมน์</a:t>
                       </a:r>
-                      <a:endParaRPr lang="en-US" sz="1500" dirty="0">
+                      <a:endParaRPr lang="en-US" sz="1400" dirty="0">
                         <a:latin typeface="Leelawadee UI" charset="0"/>
                         <a:ea typeface="Leelawadee UI" charset="0"/>
                         <a:cs typeface="Leelawadee UI" charset="0"/>
@@ -12510,7 +12510,7 @@
                   </a:tcPr>
                 </a:tc>
               </a:tr>
-              <a:tr h="566928">
+              <a:tr h="512064">
                 <a:tc>
                   <a:txBody>
                     <a:bodyPr/>
@@ -12520,7 +12520,7 @@
                         <a:buNone/>
                       </a:pPr>
                       <a:r>
-                        <a:rPr lang="en-US" sz="1500" dirty="0">
+                        <a:rPr lang="en-US" sz="1400" dirty="0">
                           <a:solidFill>
                             <a:srgbClr val="111111"/>
                           </a:solidFill>
@@ -12530,7 +12530,7 @@
                         </a:rPr>
                         <a:t>หน้าเข้าสู่ระบบเปิดเผยรหัสผ่าน</a:t>
                       </a:r>
-                      <a:endParaRPr lang="en-US" sz="1500" dirty="0">
+                      <a:endParaRPr lang="en-US" sz="1400" dirty="0">
                         <a:latin typeface="Leelawadee UI" charset="0"/>
                         <a:ea typeface="Leelawadee UI" charset="0"/>
                         <a:cs typeface="Leelawadee UI" charset="0"/>
@@ -12588,7 +12588,7 @@
                         <a:buNone/>
                       </a:pPr>
                       <a:r>
-                        <a:rPr lang="en-US" sz="1500" dirty="0">
+                        <a:rPr lang="en-US" sz="1400" dirty="0">
                           <a:solidFill>
                             <a:srgbClr val="111111"/>
                           </a:solidFill>
@@ -12598,7 +12598,7 @@
                         </a:rPr>
                         <a:t>นำออก ส่งบัญชีแยกช่องทาง</a:t>
                       </a:r>
-                      <a:endParaRPr lang="en-US" sz="1500" dirty="0">
+                      <a:endParaRPr lang="en-US" sz="1400" dirty="0">
                         <a:latin typeface="Leelawadee UI" charset="0"/>
                         <a:ea typeface="Leelawadee UI" charset="0"/>
                         <a:cs typeface="Leelawadee UI" charset="0"/>
@@ -12648,7 +12648,7 @@
                   </a:tcPr>
                 </a:tc>
               </a:tr>
-              <a:tr h="566928">
+              <a:tr h="512064">
                 <a:tc>
                   <a:txBody>
                     <a:bodyPr/>
@@ -12658,7 +12658,7 @@
                         <a:buNone/>
                       </a:pPr>
                       <a:r>
-                        <a:rPr lang="en-US" sz="1500" dirty="0">
+                        <a:rPr lang="en-US" sz="1400" dirty="0">
                           <a:solidFill>
                             <a:srgbClr val="111111"/>
                           </a:solidFill>
@@ -12668,7 +12668,7 @@
                         </a:rPr>
                         <a:t>ต้องแยกฐานข้อมูล</a:t>
                       </a:r>
-                      <a:endParaRPr lang="en-US" sz="1500" dirty="0">
+                      <a:endParaRPr lang="en-US" sz="1400" dirty="0">
                         <a:latin typeface="Leelawadee UI" charset="0"/>
                         <a:ea typeface="Leelawadee UI" charset="0"/>
                         <a:cs typeface="Leelawadee UI" charset="0"/>
@@ -12726,7 +12726,7 @@
                         <a:buNone/>
                       </a:pPr>
                       <a:r>
-                        <a:rPr lang="en-US" sz="1500" dirty="0">
+                        <a:rPr lang="en-US" sz="1400" dirty="0">
                           <a:solidFill>
                             <a:srgbClr val="111111"/>
                           </a:solidFill>
@@ -12736,7 +12736,7 @@
                         </a:rPr>
                         <a:t>schema SmartCMU + role smartcmu_app</a:t>
                       </a:r>
-                      <a:endParaRPr lang="en-US" sz="1500" dirty="0">
+                      <a:endParaRPr lang="en-US" sz="1400" dirty="0">
                         <a:latin typeface="Leelawadee UI" charset="0"/>
                         <a:ea typeface="Leelawadee UI" charset="0"/>
                         <a:cs typeface="Leelawadee UI" charset="0"/>
@@ -12786,7 +12786,7 @@
                   </a:tcPr>
                 </a:tc>
               </a:tr>
-              <a:tr h="566928">
+              <a:tr h="512064">
                 <a:tc>
                   <a:txBody>
                     <a:bodyPr/>
@@ -12796,7 +12796,7 @@
                         <a:buNone/>
                       </a:pPr>
                       <a:r>
-                        <a:rPr lang="en-US" sz="1500" dirty="0">
+                        <a:rPr lang="en-US" sz="1400" dirty="0">
                           <a:solidFill>
                             <a:srgbClr val="111111"/>
                           </a:solidFill>
@@ -12806,7 +12806,7 @@
                         </a:rPr>
                         <a:t>เปลี่ยนบัญชีแล้วเห็นข้อมูลเดิม</a:t>
                       </a:r>
-                      <a:endParaRPr lang="en-US" sz="1500" dirty="0">
+                      <a:endParaRPr lang="en-US" sz="1400" dirty="0">
                         <a:latin typeface="Leelawadee UI" charset="0"/>
                         <a:ea typeface="Leelawadee UI" charset="0"/>
                         <a:cs typeface="Leelawadee UI" charset="0"/>
@@ -12864,7 +12864,7 @@
                         <a:buNone/>
                       </a:pPr>
                       <a:r>
-                        <a:rPr lang="en-US" sz="1500" dirty="0">
+                        <a:rPr lang="en-US" sz="1400" dirty="0">
                           <a:solidFill>
                             <a:srgbClr val="111111"/>
                           </a:solidFill>
@@ -12874,7 +12874,7 @@
                         </a:rPr>
                         <a:t>ปิดแคชหน้าส่วนตัว ล้างแคชเมื่อเข้า/ออก</a:t>
                       </a:r>
-                      <a:endParaRPr lang="en-US" sz="1500" dirty="0">
+                      <a:endParaRPr lang="en-US" sz="1400" dirty="0">
                         <a:latin typeface="Leelawadee UI" charset="0"/>
                         <a:ea typeface="Leelawadee UI" charset="0"/>
                         <a:cs typeface="Leelawadee UI" charset="0"/>
@@ -12924,7 +12924,7 @@
                   </a:tcPr>
                 </a:tc>
               </a:tr>
-              <a:tr h="566928">
+              <a:tr h="512064">
                 <a:tc>
                   <a:txBody>
                     <a:bodyPr/>
@@ -12934,7 +12934,7 @@
                         <a:buNone/>
                       </a:pPr>
                       <a:r>
-                        <a:rPr lang="en-US" sz="1500" dirty="0">
+                        <a:rPr lang="en-US" sz="1400" dirty="0">
                           <a:solidFill>
                             <a:srgbClr val="111111"/>
                           </a:solidFill>
@@ -12944,7 +12944,7 @@
                         </a:rPr>
                         <a:t>เว็บช้า</a:t>
                       </a:r>
-                      <a:endParaRPr lang="en-US" sz="1500" dirty="0">
+                      <a:endParaRPr lang="en-US" sz="1400" dirty="0">
                         <a:latin typeface="Leelawadee UI" charset="0"/>
                         <a:ea typeface="Leelawadee UI" charset="0"/>
                         <a:cs typeface="Leelawadee UI" charset="0"/>
@@ -13002,7 +13002,7 @@
                         <a:buNone/>
                       </a:pPr>
                       <a:r>
-                        <a:rPr lang="en-US" sz="1500" dirty="0">
+                        <a:rPr lang="en-US" sz="1400" dirty="0">
                           <a:solidFill>
                             <a:srgbClr val="111111"/>
                           </a:solidFill>
@@ -13012,7 +13012,7 @@
                         </a:rPr>
                         <a:t>ย้าย Vercel สิงคโปร์ เพิ่มดัชนี ลดรอบคิวรี</a:t>
                       </a:r>
-                      <a:endParaRPr lang="en-US" sz="1500" dirty="0">
+                      <a:endParaRPr lang="en-US" sz="1400" dirty="0">
                         <a:latin typeface="Leelawadee UI" charset="0"/>
                         <a:ea typeface="Leelawadee UI" charset="0"/>
                         <a:cs typeface="Leelawadee UI" charset="0"/>
@@ -13062,7 +13062,7 @@
                   </a:tcPr>
                 </a:tc>
               </a:tr>
-              <a:tr h="566928">
+              <a:tr h="512064">
                 <a:tc>
                   <a:txBody>
                     <a:bodyPr/>
@@ -13072,7 +13072,7 @@
                         <a:buNone/>
                       </a:pPr>
                       <a:r>
-                        <a:rPr lang="en-US" sz="1500" dirty="0">
+                        <a:rPr lang="en-US" sz="1400" dirty="0">
                           <a:solidFill>
                             <a:srgbClr val="111111"/>
                           </a:solidFill>
@@ -13082,7 +13082,7 @@
                         </a:rPr>
                         <a:t>ข้อมูลอาคารไม่ตรงจริง</a:t>
                       </a:r>
-                      <a:endParaRPr lang="en-US" sz="1500" dirty="0">
+                      <a:endParaRPr lang="en-US" sz="1400" dirty="0">
                         <a:latin typeface="Leelawadee UI" charset="0"/>
                         <a:ea typeface="Leelawadee UI" charset="0"/>
                         <a:cs typeface="Leelawadee UI" charset="0"/>
@@ -13140,7 +13140,7 @@
                         <a:buNone/>
                       </a:pPr>
                       <a:r>
-                        <a:rPr lang="en-US" sz="1500" dirty="0">
+                        <a:rPr lang="en-US" sz="1400" dirty="0">
                           <a:solidFill>
                             <a:srgbClr val="111111"/>
                           </a:solidFill>
@@ -13150,7 +13150,7 @@
                         </a:rPr>
                         <a:t>87 อาคาร 457 ห้อง · ILC-A/B/C อยู่ใน TLIC</a:t>
                       </a:r>
-                      <a:endParaRPr lang="en-US" sz="1500" dirty="0">
+                      <a:endParaRPr lang="en-US" sz="1400" dirty="0">
                         <a:latin typeface="Leelawadee UI" charset="0"/>
                         <a:ea typeface="Leelawadee UI" charset="0"/>
                         <a:cs typeface="Leelawadee UI" charset="0"/>
@@ -13200,7 +13200,7 @@
                   </a:tcPr>
                 </a:tc>
               </a:tr>
-              <a:tr h="566928">
+              <a:tr h="512064">
                 <a:tc>
                   <a:txBody>
                     <a:bodyPr/>
@@ -13210,7 +13210,7 @@
                         <a:buNone/>
                       </a:pPr>
                       <a:r>
-                        <a:rPr lang="en-US" sz="1500" dirty="0">
+                        <a:rPr lang="en-US" sz="1400" dirty="0">
                           <a:solidFill>
                             <a:srgbClr val="111111"/>
                           </a:solidFill>
@@ -13220,7 +13220,7 @@
                         </a:rPr>
                         <a:t>ปุ่มสลับเพี้ยน / PDF ส่งออกไม่ได้</a:t>
                       </a:r>
-                      <a:endParaRPr lang="en-US" sz="1500" dirty="0">
+                      <a:endParaRPr lang="en-US" sz="1400" dirty="0">
                         <a:latin typeface="Leelawadee UI" charset="0"/>
                         <a:ea typeface="Leelawadee UI" charset="0"/>
                         <a:cs typeface="Leelawadee UI" charset="0"/>
@@ -13278,7 +13278,7 @@
                         <a:buNone/>
                       </a:pPr>
                       <a:r>
-                        <a:rPr lang="en-US" sz="1500" dirty="0">
+                        <a:rPr lang="en-US" sz="1400" dirty="0">
                           <a:solidFill>
                             <a:srgbClr val="111111"/>
                           </a:solidFill>
@@ -13288,7 +13288,7 @@
                         </a:rPr>
                         <a:t>แก้ตำแหน่งปุ่ม รวมไฟล์ฟอนต์ pdfkit ตอน deploy</a:t>
                       </a:r>
-                      <a:endParaRPr lang="en-US" sz="1500" dirty="0">
+                      <a:endParaRPr lang="en-US" sz="1400" dirty="0">
                         <a:latin typeface="Leelawadee UI" charset="0"/>
                         <a:ea typeface="Leelawadee UI" charset="0"/>
                         <a:cs typeface="Leelawadee UI" charset="0"/>
@@ -13334,6 +13334,144 @@
                     </a:lnB>
                     <a:solidFill>
                       <a:srgbClr val="F5F5F7"/>
+                    </a:solidFill>
+                  </a:tcPr>
+                </a:tc>
+              </a:tr>
+              <a:tr h="512064">
+                <a:tc>
+                  <a:txBody>
+                    <a:bodyPr/>
+                    <a:lstStyle/>
+                    <a:p>
+                      <a:pPr indent="0" marL="0">
+                        <a:buNone/>
+                      </a:pPr>
+                      <a:r>
+                        <a:rPr lang="en-US" sz="1400" dirty="0">
+                          <a:solidFill>
+                            <a:srgbClr val="111111"/>
+                          </a:solidFill>
+                          <a:latin typeface="Leelawadee UI" pitchFamily="34" charset="0"/>
+                          <a:ea typeface="Leelawadee UI" pitchFamily="34" charset="-122"/>
+                          <a:cs typeface="Leelawadee UI" pitchFamily="34" charset="-120"/>
+                        </a:rPr>
+                        <a:t>ตรวจความปลอดภัยและ UI ทุกหน้าก่อนส่ง</a:t>
+                      </a:r>
+                      <a:endParaRPr lang="en-US" sz="1400" dirty="0">
+                        <a:latin typeface="Leelawadee UI" charset="0"/>
+                        <a:ea typeface="Leelawadee UI" charset="0"/>
+                        <a:cs typeface="Leelawadee UI" charset="0"/>
+                      </a:endParaRPr>
+                    </a:p>
+                  </a:txBody>
+                  <a:tcPr marL="91440" marR="91440" marT="45720" marB="45720" anchor="ctr">
+                    <a:lnL w="9525" cap="flat" cmpd="sng" algn="ctr">
+                      <a:solidFill>
+                        <a:srgbClr val="E3DCEA"/>
+                      </a:solidFill>
+                      <a:prstDash val="solid"/>
+                      <a:round/>
+                      <a:headEnd type="none" w="med" len="med"/>
+                      <a:tailEnd type="none" w="med" len="med"/>
+                    </a:lnL>
+                    <a:lnR w="9525" cap="flat" cmpd="sng" algn="ctr">
+                      <a:solidFill>
+                        <a:srgbClr val="E3DCEA"/>
+                      </a:solidFill>
+                      <a:prstDash val="solid"/>
+                      <a:round/>
+                      <a:headEnd type="none" w="med" len="med"/>
+                      <a:tailEnd type="none" w="med" len="med"/>
+                    </a:lnR>
+                    <a:lnT w="9525" cap="flat" cmpd="sng" algn="ctr">
+                      <a:solidFill>
+                        <a:srgbClr val="E3DCEA"/>
+                      </a:solidFill>
+                      <a:prstDash val="solid"/>
+                      <a:round/>
+                      <a:headEnd type="none" w="med" len="med"/>
+                      <a:tailEnd type="none" w="med" len="med"/>
+                    </a:lnT>
+                    <a:lnB w="9525" cap="flat" cmpd="sng" algn="ctr">
+                      <a:solidFill>
+                        <a:srgbClr val="E3DCEA"/>
+                      </a:solidFill>
+                      <a:prstDash val="solid"/>
+                      <a:round/>
+                      <a:headEnd type="none" w="med" len="med"/>
+                      <a:tailEnd type="none" w="med" len="med"/>
+                    </a:lnB>
+                    <a:solidFill>
+                      <a:srgbClr val="FFFFFF"/>
+                    </a:solidFill>
+                  </a:tcPr>
+                </a:tc>
+                <a:tc>
+                  <a:txBody>
+                    <a:bodyPr/>
+                    <a:lstStyle/>
+                    <a:p>
+                      <a:pPr indent="0" marL="0">
+                        <a:buNone/>
+                      </a:pPr>
+                      <a:r>
+                        <a:rPr lang="en-US" sz="1400" dirty="0">
+                          <a:solidFill>
+                            <a:srgbClr val="111111"/>
+                          </a:solidFill>
+                          <a:latin typeface="Leelawadee UI" pitchFamily="34" charset="0"/>
+                          <a:ea typeface="Leelawadee UI" pitchFamily="34" charset="-122"/>
+                          <a:cs typeface="Leelawadee UI" pitchFamily="34" charset="-120"/>
+                        </a:rPr>
+                        <a:t>จำกัดรหัสผิด ซ่อนชื่อผู้แจ้ง · แก้เมนูมือถือ เพิ่มค้นหาอาคาร</a:t>
+                      </a:r>
+                      <a:endParaRPr lang="en-US" sz="1400" dirty="0">
+                        <a:latin typeface="Leelawadee UI" charset="0"/>
+                        <a:ea typeface="Leelawadee UI" charset="0"/>
+                        <a:cs typeface="Leelawadee UI" charset="0"/>
+                      </a:endParaRPr>
+                    </a:p>
+                  </a:txBody>
+                  <a:tcPr marL="91440" marR="91440" marT="45720" marB="45720" anchor="ctr">
+                    <a:lnL w="9525" cap="flat" cmpd="sng" algn="ctr">
+                      <a:solidFill>
+                        <a:srgbClr val="E3DCEA"/>
+                      </a:solidFill>
+                      <a:prstDash val="solid"/>
+                      <a:round/>
+                      <a:headEnd type="none" w="med" len="med"/>
+                      <a:tailEnd type="none" w="med" len="med"/>
+                    </a:lnL>
+                    <a:lnR w="9525" cap="flat" cmpd="sng" algn="ctr">
+                      <a:solidFill>
+                        <a:srgbClr val="E3DCEA"/>
+                      </a:solidFill>
+                      <a:prstDash val="solid"/>
+                      <a:round/>
+                      <a:headEnd type="none" w="med" len="med"/>
+                      <a:tailEnd type="none" w="med" len="med"/>
+                    </a:lnR>
+                    <a:lnT w="9525" cap="flat" cmpd="sng" algn="ctr">
+                      <a:solidFill>
+                        <a:srgbClr val="E3DCEA"/>
+                      </a:solidFill>
+                      <a:prstDash val="solid"/>
+                      <a:round/>
+                      <a:headEnd type="none" w="med" len="med"/>
+                      <a:tailEnd type="none" w="med" len="med"/>
+                    </a:lnT>
+                    <a:lnB w="9525" cap="flat" cmpd="sng" algn="ctr">
+                      <a:solidFill>
+                        <a:srgbClr val="E3DCEA"/>
+                      </a:solidFill>
+                      <a:prstDash val="solid"/>
+                      <a:round/>
+                      <a:headEnd type="none" w="med" len="med"/>
+                      <a:tailEnd type="none" w="med" len="med"/>
+                    </a:lnB>
+                    <a:solidFill>
+                      <a:srgbClr val="FFFFFF"/>
                     </a:solidFill>
                   </a:tcPr>
                 </a:tc>

</xml_diff>

<commit_message>
Add Social Sciences, Engineering and Nursing buildings from the faculty maps
- Social Sciences (SOCMAP 2026): buildings 1A/1B/2/3/4, the laboratory building
  (04107), International Building and cafeteria, with offices and rooms per floor
- Engineering (ENTANEER MAP): 30th Anniversary Building (Computer Engineering on
  floors 4-5), 3- and 4-storey lecture halls, departments, library, canteen and
  outdoor areas
- Nursing: Building 4, NT Building, five nursing dormitories and the garage
- 119 buildings, 641 rooms. db/locations-sync.sql applies this in the Supabase
  SQL Editor (renames and additions only; tested twice on a copy of the old data)
- Report and slides updated to the new counts

Co-Authored-By: Claude Opus 5 <noreply@anthropic.com>
</commit_message>
<xml_diff>
--- a/report/out/สไลด์-ระบบแจ้งซ่อม-มช.pptx
+++ b/report/out/สไลด์-ระบบแจ้งซ่อม-มช.pptx
@@ -7665,7 +7665,7 @@
                 <a:ea typeface="Leelawadee UI" pitchFamily="34" charset="-122"/>
                 <a:cs typeface="Leelawadee UI" pitchFamily="34" charset="-120"/>
               </a:rPr>
-              <a:t>ข้อมูลจริง 3 วิทยาเขต 87 อาคาร 457 ห้อง</a:t>
+              <a:t>ข้อมูลจริง 3 วิทยาเขต 119 อาคาร 641 ห้อง</a:t>
             </a:r>
             <a:endParaRPr lang="en-US" sz="1500" dirty="0"/>
           </a:p>
@@ -13148,7 +13148,7 @@
                           <a:ea typeface="Leelawadee UI" pitchFamily="34" charset="-122"/>
                           <a:cs typeface="Leelawadee UI" pitchFamily="34" charset="-120"/>
                         </a:rPr>
-                        <a:t>87 อาคาร 457 ห้อง · ILC-A/B/C อยู่ใน TLIC</a:t>
+                        <a:t>119 อาคาร 641 ห้อง รวมแผนที่สังคมฯ วิศวะ พยาบาล · ILC อยู่ใน TLIC</a:t>
                       </a:r>
                       <a:endParaRPr lang="en-US" sz="1400" dirty="0">
                         <a:latin typeface="Leelawadee UI" charset="0"/>

</xml_diff>

<commit_message>
Add the Faculty of Economics floor plans and show G and B floors
- ECB1 and ECB2 get their real rooms and offices per floor (ECB1201, the
  faculty offices ECB1301-1348, research centres, study rooms); ECB3 is new
- Rooms can be renamed in place (EC1201 -> ECB1201) so requests keep them;
  both sync-locations and db/locations-sync.sql apply the renames
- Floor 0 shows as ชั้น G and -1 as ชั้น B1 everywhere a floor is displayed;
  the Subaltern Room of the Social Sciences lab building moves to B1
- 120 buildings, 747 rooms; report and slides updated

Co-Authored-By: Claude Opus 5 <noreply@anthropic.com>
</commit_message>
<xml_diff>
--- a/report/out/สไลด์-ระบบแจ้งซ่อม-มช.pptx
+++ b/report/out/สไลด์-ระบบแจ้งซ่อม-มช.pptx
@@ -7665,7 +7665,7 @@
                 <a:ea typeface="Leelawadee UI" pitchFamily="34" charset="-122"/>
                 <a:cs typeface="Leelawadee UI" pitchFamily="34" charset="-120"/>
               </a:rPr>
-              <a:t>ข้อมูลจริง 3 วิทยาเขต 119 อาคาร 641 ห้อง</a:t>
+              <a:t>ข้อมูลจริง 3 วิทยาเขต 120 อาคาร 747 ห้อง</a:t>
             </a:r>
             <a:endParaRPr lang="en-US" sz="1500" dirty="0"/>
           </a:p>
@@ -13148,7 +13148,7 @@
                           <a:ea typeface="Leelawadee UI" pitchFamily="34" charset="-122"/>
                           <a:cs typeface="Leelawadee UI" pitchFamily="34" charset="-120"/>
                         </a:rPr>
-                        <a:t>119 อาคาร 641 ห้อง รวมแผนที่สังคมฯ วิศวะ พยาบาล · ILC อยู่ใน TLIC</a:t>
+                        <a:t>120 อาคาร 747 ห้อง รวมแผนที่สังคมฯ วิศวะ เศรษฐศาสตร์ พยาบาล · ILC อยู่ใน TLIC</a:t>
                       </a:r>
                       <a:endParaRPr lang="en-US" sz="1400" dirty="0">
                         <a:latin typeface="Leelawadee UI" charset="0"/>

</xml_diff>

<commit_message>
Add Agriculture, Education, Mathematics (MB2), Agro-Industry and Humanities buildings
- Agriculture (agri.cmu.ac.th building map): AB1-AB5 and faculty facilities;
  AB5 floors 3-4 room by room with seat counts
- MB2 floors 1-3 from the floor plans (offices, MB2211 Slope Math, meeting room)
- Education map: named rooms in EB1-EB4, EB5-EB9, centres, cafeteria, grounds,
  and the demonstration school
- Agro-Industry map: AGI1-AGI3 get their programme names, AGI4-AGI5 and
  facilities are new; Humanities HB4 and HB6
- 156 buildings, 960 rooms; db/locations-sync.sql regenerated and tested from
  every earlier state; report and slides updated

Co-Authored-By: Claude Opus 5 <noreply@anthropic.com>
</commit_message>
<xml_diff>
--- a/report/out/สไลด์-ระบบแจ้งซ่อม-มช.pptx
+++ b/report/out/สไลด์-ระบบแจ้งซ่อม-มช.pptx
@@ -7665,7 +7665,7 @@
                 <a:ea typeface="Leelawadee UI" pitchFamily="34" charset="-122"/>
                 <a:cs typeface="Leelawadee UI" pitchFamily="34" charset="-120"/>
               </a:rPr>
-              <a:t>ข้อมูลจริง 3 วิทยาเขต 120 อาคาร 747 ห้อง</a:t>
+              <a:t>ข้อมูลจริง 3 วิทยาเขต 156 อาคาร 960 ห้อง</a:t>
             </a:r>
             <a:endParaRPr lang="en-US" sz="1500" dirty="0"/>
           </a:p>
@@ -13148,7 +13148,7 @@
                           <a:ea typeface="Leelawadee UI" pitchFamily="34" charset="-122"/>
                           <a:cs typeface="Leelawadee UI" pitchFamily="34" charset="-120"/>
                         </a:rPr>
-                        <a:t>120 อาคาร 747 ห้อง รวมแผนที่สังคมฯ วิศวะ เศรษฐศาสตร์ พยาบาล · ILC อยู่ใน TLIC</a:t>
+                        <a:t>156 อาคาร 960 ห้อง จากแผนที่และผังของ 10 คณะ · ILC อยู่ใน TLIC</a:t>
                       </a:r>
                       <a:endParaRPr lang="en-US" sz="1400" dirty="0">
                         <a:latin typeface="Leelawadee UI" charset="0"/>

</xml_diff>

<commit_message>
Pick the faculty before the building; add ICDI
- Location step is now campus → faculty/unit → building → floor → room.
  Suan Sak has 120+ buildings; the faculty list is about 20 rows. Typing in
  the search box still finds any building of the campus by code or name, and
  a faculty with one building (CAMT, ICDI) goes straight to its floors
- buildings.faculty_th (migration 004); db/locations.ts assigns every listed
  building by rules; sync-locations and db/locations-sync.sql fill it in.
  The catalog query falls back when the column is not there yet
- Admin: faculty filter and group headers in ข้อมูลพื้นฐาน → สถานที่, a faculty
  field (with suggestions) when editing a building, and the request filter's
  building list grouped by faculty
- ICDI: floor 3 of the University Administration Building 3
- Figma: new step R05a (faculty list with search); 78 screens, 415 links
- Report, slides, activity diagram and IA updated

Co-Authored-By: Claude Opus 5 <noreply@anthropic.com>
</commit_message>
<xml_diff>
--- a/report/out/สไลด์-ระบบแจ้งซ่อม-มช.pptx
+++ b/report/out/สไลด์-ระบบแจ้งซ่อม-มช.pptx
@@ -2682,8 +2682,8 @@
         </p:blipFill>
         <p:spPr>
           <a:xfrm>
-            <a:off x="956076" y="1371600"/>
-            <a:ext cx="2111207" cy="5349240"/>
+            <a:off x="969457" y="1371600"/>
+            <a:ext cx="2084446" cy="5349240"/>
           </a:xfrm>
           <a:prstGeom prst="rect">
             <a:avLst/>
@@ -3312,8 +3312,8 @@
         </p:blipFill>
         <p:spPr>
           <a:xfrm>
-            <a:off x="1058482" y="1371600"/>
-            <a:ext cx="3735195" cy="5349240"/>
+            <a:off x="874336" y="1371600"/>
+            <a:ext cx="4103489" cy="5349240"/>
           </a:xfrm>
           <a:prstGeom prst="rect">
             <a:avLst/>
@@ -4185,7 +4185,7 @@
                 <a:ea typeface="Leelawadee UI" pitchFamily="34" charset="-122"/>
                 <a:cs typeface="Leelawadee UI" pitchFamily="34" charset="-120"/>
               </a:rPr>
-              <a:t>76</a:t>
+              <a:t>78</a:t>
             </a:r>
             <a:endParaRPr lang="en-US" sz="4000" dirty="0"/>
           </a:p>
@@ -4395,7 +4395,7 @@
                 <a:ea typeface="Leelawadee UI" pitchFamily="34" charset="-122"/>
                 <a:cs typeface="Leelawadee UI" pitchFamily="34" charset="-120"/>
               </a:rPr>
-              <a:t>401</a:t>
+              <a:t>415</a:t>
             </a:r>
             <a:endParaRPr lang="en-US" sz="4000" dirty="0"/>
           </a:p>
@@ -7665,7 +7665,7 @@
                 <a:ea typeface="Leelawadee UI" pitchFamily="34" charset="-122"/>
                 <a:cs typeface="Leelawadee UI" pitchFamily="34" charset="-120"/>
               </a:rPr>
-              <a:t>ข้อมูลจริง 3 วิทยาเขต 156 อาคาร 960 ห้อง</a:t>
+              <a:t>ข้อมูลจริง 3 วิทยาเขต 157 อาคาร 965 ห้อง เลือกคณะก่อนอาคาร</a:t>
             </a:r>
             <a:endParaRPr lang="en-US" sz="1500" dirty="0"/>
           </a:p>
@@ -13148,7 +13148,7 @@
                           <a:ea typeface="Leelawadee UI" pitchFamily="34" charset="-122"/>
                           <a:cs typeface="Leelawadee UI" pitchFamily="34" charset="-120"/>
                         </a:rPr>
-                        <a:t>156 อาคาร 960 ห้อง จากแผนที่และผังของ 10 คณะ · ILC อยู่ใน TLIC</a:t>
+                        <a:t>157 อาคาร 965 ห้องจากผังของคณะต่าง ๆ · เลือกคณะก่อนอาคาร</a:t>
                       </a:r>
                       <a:endParaRPr lang="en-US" sz="1400" dirty="0">
                         <a:latin typeface="Leelawadee UI" charset="0"/>

</xml_diff>